<commit_message>
PPT új taskokkal kiegészítve
PPT új taskokkal kiegészítve
</commit_message>
<xml_diff>
--- a/doc/Automated Emergency Brake Group2 HUN.pptx
+++ b/doc/Automated Emergency Brake Group2 HUN.pptx
@@ -120,20 +120,12 @@
 </p:presentation>
 </file>
 
-<file path=ppt/revisionInfo.xml><?xml version="1.0" encoding="utf-8"?>
-<p1510:revInfo xmlns:a="http://schemas.openxmlformats.org/drawingml/2006/main" xmlns:r="http://schemas.openxmlformats.org/officeDocument/2006/relationships" xmlns:p1510="http://schemas.microsoft.com/office/powerpoint/2015/10/main">
-  <p1510:revLst>
-    <p1510:client id="{46E060B1-5F1C-41C8-B681-E99EC520B449}" v="12" dt="2026-04-19T21:37:19.558"/>
-  </p1510:revLst>
-</p1510:revInfo>
-</file>
-
 <file path=ppt/changesInfos/changesInfo1.xml><?xml version="1.0" encoding="utf-8"?>
 <pc:chgInfo xmlns:a="http://schemas.openxmlformats.org/drawingml/2006/main" xmlns:r="http://schemas.openxmlformats.org/officeDocument/2006/relationships" xmlns:ac="http://schemas.microsoft.com/office/drawing/2013/main/command" xmlns:pc="http://schemas.microsoft.com/office/powerpoint/2013/main/command">
   <pc:docChgLst>
     <pc:chgData name="Horváth Gábor Timót" userId="6b190c0b-b7a5-44d6-a153-62faea1c1e8d" providerId="ADAL" clId="{E9885F06-42F8-43E5-9640-56F69EAE1246}"/>
     <pc:docChg chg="custSel addSld modSld">
-      <pc:chgData name="Horváth Gábor Timót" userId="6b190c0b-b7a5-44d6-a153-62faea1c1e8d" providerId="ADAL" clId="{E9885F06-42F8-43E5-9640-56F69EAE1246}" dt="2026-04-19T21:37:27.252" v="839" actId="20577"/>
+      <pc:chgData name="Horváth Gábor Timót" userId="6b190c0b-b7a5-44d6-a153-62faea1c1e8d" providerId="ADAL" clId="{E9885F06-42F8-43E5-9640-56F69EAE1246}" dt="2026-04-28T09:56:42.394" v="894" actId="20577"/>
       <pc:docMkLst>
         <pc:docMk/>
       </pc:docMkLst>
@@ -299,7 +291,7 @@
         </pc:spChg>
       </pc:sldChg>
       <pc:sldChg chg="modSp new mod">
-        <pc:chgData name="Horváth Gábor Timót" userId="6b190c0b-b7a5-44d6-a153-62faea1c1e8d" providerId="ADAL" clId="{E9885F06-42F8-43E5-9640-56F69EAE1246}" dt="2026-04-19T21:35:02.191" v="749"/>
+        <pc:chgData name="Horváth Gábor Timót" userId="6b190c0b-b7a5-44d6-a153-62faea1c1e8d" providerId="ADAL" clId="{E9885F06-42F8-43E5-9640-56F69EAE1246}" dt="2026-04-28T09:56:42.394" v="894" actId="20577"/>
         <pc:sldMkLst>
           <pc:docMk/>
           <pc:sldMk cId="924554517" sldId="263"/>
@@ -313,7 +305,7 @@
           </ac:spMkLst>
         </pc:spChg>
         <pc:spChg chg="mod">
-          <ac:chgData name="Horváth Gábor Timót" userId="6b190c0b-b7a5-44d6-a153-62faea1c1e8d" providerId="ADAL" clId="{E9885F06-42F8-43E5-9640-56F69EAE1246}" dt="2026-04-19T21:35:02.191" v="749"/>
+          <ac:chgData name="Horváth Gábor Timót" userId="6b190c0b-b7a5-44d6-a153-62faea1c1e8d" providerId="ADAL" clId="{E9885F06-42F8-43E5-9640-56F69EAE1246}" dt="2026-04-28T09:56:42.394" v="894" actId="20577"/>
           <ac:spMkLst>
             <pc:docMk/>
             <pc:sldMk cId="924554517" sldId="263"/>
@@ -517,7 +509,7 @@
             <a:fld id="{5816CF25-28A6-44B7-AA26-A9DDEE15FAB8}" type="datetimeFigureOut">
               <a:rPr lang="hu-HU" smtClean="0"/>
               <a:pPr/>
-              <a:t>2026. 04. 19.</a:t>
+              <a:t>2026. 04. 28.</a:t>
             </a:fld>
             <a:endParaRPr lang="hu-HU"/>
           </a:p>
@@ -767,7 +759,7 @@
             <a:fld id="{5816CF25-28A6-44B7-AA26-A9DDEE15FAB8}" type="datetimeFigureOut">
               <a:rPr lang="hu-HU" smtClean="0"/>
               <a:pPr/>
-              <a:t>2026. 04. 19.</a:t>
+              <a:t>2026. 04. 28.</a:t>
             </a:fld>
             <a:endParaRPr lang="hu-HU"/>
           </a:p>
@@ -1051,7 +1043,7 @@
             <a:fld id="{5816CF25-28A6-44B7-AA26-A9DDEE15FAB8}" type="datetimeFigureOut">
               <a:rPr lang="hu-HU" smtClean="0"/>
               <a:pPr/>
-              <a:t>2026. 04. 19.</a:t>
+              <a:t>2026. 04. 28.</a:t>
             </a:fld>
             <a:endParaRPr lang="hu-HU" dirty="0"/>
           </a:p>
@@ -1397,7 +1389,7 @@
             <a:fld id="{5816CF25-28A6-44B7-AA26-A9DDEE15FAB8}" type="datetimeFigureOut">
               <a:rPr lang="hu-HU" smtClean="0"/>
               <a:pPr/>
-              <a:t>2026. 04. 19.</a:t>
+              <a:t>2026. 04. 28.</a:t>
             </a:fld>
             <a:endParaRPr lang="hu-HU" dirty="0"/>
           </a:p>
@@ -1555,7 +1547,7 @@
             <a:fld id="{5816CF25-28A6-44B7-AA26-A9DDEE15FAB8}" type="datetimeFigureOut">
               <a:rPr lang="hu-HU" smtClean="0"/>
               <a:pPr/>
-              <a:t>2026. 04. 19.</a:t>
+              <a:t>2026. 04. 28.</a:t>
             </a:fld>
             <a:endParaRPr lang="hu-HU"/>
           </a:p>
@@ -1672,7 +1664,7 @@
             <a:fld id="{5816CF25-28A6-44B7-AA26-A9DDEE15FAB8}" type="datetimeFigureOut">
               <a:rPr lang="hu-HU" smtClean="0"/>
               <a:pPr/>
-              <a:t>2026. 04. 19.</a:t>
+              <a:t>2026. 04. 28.</a:t>
             </a:fld>
             <a:endParaRPr lang="hu-HU"/>
           </a:p>
@@ -1894,7 +1886,7 @@
           <a:p>
             <a:fld id="{5816CF25-28A6-44B7-AA26-A9DDEE15FAB8}" type="datetimeFigureOut">
               <a:rPr lang="hu-HU" smtClean="0"/>
-              <a:t>2026. 04. 19.</a:t>
+              <a:t>2026. 04. 28.</a:t>
             </a:fld>
             <a:endParaRPr lang="hu-HU"/>
           </a:p>
@@ -2832,6 +2824,33 @@
               <a:rPr lang="hu-HU" dirty="0"/>
               <a:t>Beavatkozás</a:t>
             </a:r>
+          </a:p>
+          <a:p>
+            <a:pPr lvl="1"/>
+            <a:r>
+              <a:rPr lang="hu-HU" dirty="0" err="1"/>
+              <a:t>Target</a:t>
+            </a:r>
+            <a:r>
+              <a:rPr lang="hu-HU" dirty="0"/>
+              <a:t> sávon belüli vizsgálata</a:t>
+            </a:r>
+          </a:p>
+          <a:p>
+            <a:pPr lvl="1"/>
+            <a:r>
+              <a:rPr lang="hu-HU" dirty="0" err="1"/>
+              <a:t>Jerk</a:t>
+            </a:r>
+            <a:r>
+              <a:rPr lang="hu-HU" dirty="0"/>
+              <a:t> és </a:t>
+            </a:r>
+            <a:r>
+              <a:rPr lang="hu-HU"/>
+              <a:t>Gyorsulás limit</a:t>
+            </a:r>
+            <a:endParaRPr lang="hu-HU" dirty="0"/>
           </a:p>
         </p:txBody>
       </p:sp>

</xml_diff>